<commit_message>
feat: finaliza cambios de la tarea 202508221226
</commit_message>
<xml_diff>
--- a/documentacion/2025-DJANGO-5-BY-EXAMPLE_gitflow_2025.pptx
+++ b/documentacion/2025-DJANGO-5-BY-EXAMPLE_gitflow_2025.pptx
@@ -6,6 +6,7 @@
   </p:sldMasterIdLst>
   <p:sldIdLst>
     <p:sldId id="256" r:id="rId2"/>
+    <p:sldId id="257" r:id="rId3"/>
   </p:sldIdLst>
   <p:sldSz cx="9144000" cy="6858000" type="screen4x3"/>
   <p:notesSz cx="6858000" cy="9144000"/>
@@ -302,7 +303,7 @@
           <a:p>
             <a:fld id="{5BCAD085-E8A6-8845-BD4E-CB4CCA059FC4}" type="datetimeFigureOut">
               <a:rPr lang="en-US" smtClean="0"/>
-              <a:t>8/21/25</a:t>
+              <a:t>8/22/25</a:t>
             </a:fld>
             <a:endParaRPr lang="en-US"/>
           </a:p>
@@ -470,7 +471,7 @@
           <a:p>
             <a:fld id="{5BCAD085-E8A6-8845-BD4E-CB4CCA059FC4}" type="datetimeFigureOut">
               <a:rPr lang="en-US" smtClean="0"/>
-              <a:t>8/21/25</a:t>
+              <a:t>8/22/25</a:t>
             </a:fld>
             <a:endParaRPr lang="en-US"/>
           </a:p>
@@ -648,7 +649,7 @@
           <a:p>
             <a:fld id="{5BCAD085-E8A6-8845-BD4E-CB4CCA059FC4}" type="datetimeFigureOut">
               <a:rPr lang="en-US" smtClean="0"/>
-              <a:t>8/21/25</a:t>
+              <a:t>8/22/25</a:t>
             </a:fld>
             <a:endParaRPr lang="en-US"/>
           </a:p>
@@ -816,7 +817,7 @@
           <a:p>
             <a:fld id="{5BCAD085-E8A6-8845-BD4E-CB4CCA059FC4}" type="datetimeFigureOut">
               <a:rPr lang="en-US" smtClean="0"/>
-              <a:t>8/21/25</a:t>
+              <a:t>8/22/25</a:t>
             </a:fld>
             <a:endParaRPr lang="en-US"/>
           </a:p>
@@ -1061,7 +1062,7 @@
           <a:p>
             <a:fld id="{5BCAD085-E8A6-8845-BD4E-CB4CCA059FC4}" type="datetimeFigureOut">
               <a:rPr lang="en-US" smtClean="0"/>
-              <a:t>8/21/25</a:t>
+              <a:t>8/22/25</a:t>
             </a:fld>
             <a:endParaRPr lang="en-US"/>
           </a:p>
@@ -1346,7 +1347,7 @@
           <a:p>
             <a:fld id="{5BCAD085-E8A6-8845-BD4E-CB4CCA059FC4}" type="datetimeFigureOut">
               <a:rPr lang="en-US" smtClean="0"/>
-              <a:t>8/21/25</a:t>
+              <a:t>8/22/25</a:t>
             </a:fld>
             <a:endParaRPr lang="en-US"/>
           </a:p>
@@ -1765,7 +1766,7 @@
           <a:p>
             <a:fld id="{5BCAD085-E8A6-8845-BD4E-CB4CCA059FC4}" type="datetimeFigureOut">
               <a:rPr lang="en-US" smtClean="0"/>
-              <a:t>8/21/25</a:t>
+              <a:t>8/22/25</a:t>
             </a:fld>
             <a:endParaRPr lang="en-US"/>
           </a:p>
@@ -1882,7 +1883,7 @@
           <a:p>
             <a:fld id="{5BCAD085-E8A6-8845-BD4E-CB4CCA059FC4}" type="datetimeFigureOut">
               <a:rPr lang="en-US" smtClean="0"/>
-              <a:t>8/21/25</a:t>
+              <a:t>8/22/25</a:t>
             </a:fld>
             <a:endParaRPr lang="en-US"/>
           </a:p>
@@ -1977,7 +1978,7 @@
           <a:p>
             <a:fld id="{5BCAD085-E8A6-8845-BD4E-CB4CCA059FC4}" type="datetimeFigureOut">
               <a:rPr lang="en-US" smtClean="0"/>
-              <a:t>8/21/25</a:t>
+              <a:t>8/22/25</a:t>
             </a:fld>
             <a:endParaRPr lang="en-US"/>
           </a:p>
@@ -2252,7 +2253,7 @@
           <a:p>
             <a:fld id="{5BCAD085-E8A6-8845-BD4E-CB4CCA059FC4}" type="datetimeFigureOut">
               <a:rPr lang="en-US" smtClean="0"/>
-              <a:t>8/21/25</a:t>
+              <a:t>8/22/25</a:t>
             </a:fld>
             <a:endParaRPr lang="en-US"/>
           </a:p>
@@ -2504,7 +2505,7 @@
           <a:p>
             <a:fld id="{5BCAD085-E8A6-8845-BD4E-CB4CCA059FC4}" type="datetimeFigureOut">
               <a:rPr lang="en-US" smtClean="0"/>
-              <a:t>8/21/25</a:t>
+              <a:t>8/22/25</a:t>
             </a:fld>
             <a:endParaRPr lang="en-US"/>
           </a:p>
@@ -2715,7 +2716,7 @@
           <a:p>
             <a:fld id="{5BCAD085-E8A6-8845-BD4E-CB4CCA059FC4}" type="datetimeFigureOut">
               <a:rPr lang="en-US" smtClean="0"/>
-              <a:t>8/21/25</a:t>
+              <a:t>8/22/25</a:t>
             </a:fld>
             <a:endParaRPr lang="en-US"/>
           </a:p>
@@ -4939,7 +4940,7 @@
         </p:nvSpPr>
         <p:spPr>
           <a:xfrm>
-            <a:off x="4004468" y="1180794"/>
+            <a:off x="4013411" y="1238686"/>
             <a:ext cx="755335" cy="215444"/>
           </a:xfrm>
           <a:prstGeom prst="rect">
@@ -5869,7 +5870,7 @@
         </p:nvSpPr>
         <p:spPr>
           <a:xfrm>
-            <a:off x="3633367" y="1126266"/>
+            <a:off x="3643482" y="999691"/>
             <a:ext cx="755335" cy="215444"/>
           </a:xfrm>
           <a:prstGeom prst="rect">
@@ -5985,6 +5986,1774 @@
         </p:txBody>
       </p:sp>
     </p:spTree>
+  </p:cSld>
+  <p:clrMapOvr>
+    <a:masterClrMapping/>
+  </p:clrMapOvr>
+</p:sld>
+</file>
+
+<file path=ppt/slides/slide2.xml><?xml version="1.0" encoding="utf-8"?>
+<p:sld xmlns:a="http://schemas.openxmlformats.org/drawingml/2006/main" xmlns:r="http://schemas.openxmlformats.org/officeDocument/2006/relationships" xmlns:p="http://schemas.openxmlformats.org/presentationml/2006/main">
+  <p:cSld>
+    <p:spTree>
+      <p:nvGrpSpPr>
+        <p:cNvPr id="1" name=""/>
+        <p:cNvGrpSpPr/>
+        <p:nvPr/>
+      </p:nvGrpSpPr>
+      <p:grpSpPr>
+        <a:xfrm>
+          <a:off x="0" y="0"/>
+          <a:ext cx="0" cy="0"/>
+          <a:chOff x="0" y="0"/>
+          <a:chExt cx="0" cy="0"/>
+        </a:xfrm>
+      </p:grpSpPr>
+      <p:sp>
+        <p:nvSpPr>
+          <p:cNvPr id="2" name="TextBox 1"/>
+          <p:cNvSpPr txBox="1"/>
+          <p:nvPr/>
+        </p:nvSpPr>
+        <p:spPr>
+          <a:xfrm>
+            <a:off x="197269" y="104356"/>
+            <a:ext cx="6603090" cy="461665"/>
+          </a:xfrm>
+          <a:prstGeom prst="rect">
+            <a:avLst/>
+          </a:prstGeom>
+          <a:noFill/>
+        </p:spPr>
+        <p:txBody>
+          <a:bodyPr wrap="none">
+            <a:spAutoFit/>
+          </a:bodyPr>
+          <a:lstStyle/>
+          <a:p>
+            <a:r>
+              <a:rPr sz="2400" b="1" dirty="0">
+                <a:solidFill>
+                  <a:schemeClr val="accent1">
+                    <a:lumMod val="75000"/>
+                  </a:schemeClr>
+                </a:solidFill>
+                <a:latin typeface="Comic Sans MS" panose="030F0902030302020204" pitchFamily="66" charset="0"/>
+              </a:rPr>
+              <a:t>Pro</a:t>
+            </a:r>
+            <a:r>
+              <a:rPr lang="es-ES" sz="2400" b="1" dirty="0">
+                <a:solidFill>
+                  <a:schemeClr val="accent1">
+                    <a:lumMod val="75000"/>
+                  </a:schemeClr>
+                </a:solidFill>
+                <a:latin typeface="Comic Sans MS" panose="030F0902030302020204" pitchFamily="66" charset="0"/>
+              </a:rPr>
+              <a:t>ye</a:t>
+            </a:r>
+            <a:r>
+              <a:rPr sz="2400" b="1" dirty="0">
+                <a:solidFill>
+                  <a:schemeClr val="accent1">
+                    <a:lumMod val="75000"/>
+                  </a:schemeClr>
+                </a:solidFill>
+                <a:latin typeface="Comic Sans MS" panose="030F0902030302020204" pitchFamily="66" charset="0"/>
+              </a:rPr>
+              <a:t>c</a:t>
+            </a:r>
+            <a:r>
+              <a:rPr lang="es-ES" sz="2400" b="1" dirty="0">
+                <a:solidFill>
+                  <a:schemeClr val="accent1">
+                    <a:lumMod val="75000"/>
+                  </a:schemeClr>
+                </a:solidFill>
+                <a:latin typeface="Comic Sans MS" panose="030F0902030302020204" pitchFamily="66" charset="0"/>
+              </a:rPr>
+              <a:t>to</a:t>
+            </a:r>
+            <a:r>
+              <a:rPr sz="2400" b="1" dirty="0">
+                <a:solidFill>
+                  <a:schemeClr val="accent1">
+                    <a:lumMod val="75000"/>
+                  </a:schemeClr>
+                </a:solidFill>
+                <a:latin typeface="Comic Sans MS" panose="030F0902030302020204" pitchFamily="66" charset="0"/>
+              </a:rPr>
+              <a:t>: </a:t>
+            </a:r>
+            <a:r>
+              <a:rPr lang="es-ES" sz="2400" b="1" dirty="0">
+                <a:solidFill>
+                  <a:schemeClr val="accent1">
+                    <a:lumMod val="75000"/>
+                  </a:schemeClr>
+                </a:solidFill>
+                <a:latin typeface="Comic Sans MS" panose="030F0902030302020204" pitchFamily="66" charset="0"/>
+              </a:rPr>
+              <a:t>2025-DJANGO-5-BY-EXAMPLE</a:t>
+            </a:r>
+            <a:endParaRPr sz="2400" b="1" dirty="0">
+              <a:solidFill>
+                <a:schemeClr val="accent1">
+                  <a:lumMod val="75000"/>
+                </a:schemeClr>
+              </a:solidFill>
+              <a:latin typeface="Comic Sans MS" panose="030F0902030302020204" pitchFamily="66" charset="0"/>
+            </a:endParaRPr>
+          </a:p>
+        </p:txBody>
+      </p:sp>
+      <p:cxnSp>
+        <p:nvCxnSpPr>
+          <p:cNvPr id="3" name="Connector 2"/>
+          <p:cNvCxnSpPr/>
+          <p:nvPr/>
+        </p:nvCxnSpPr>
+        <p:spPr>
+          <a:xfrm>
+            <a:off x="1591291" y="914400"/>
+            <a:ext cx="7315200" cy="0"/>
+          </a:xfrm>
+          <a:prstGeom prst="line">
+            <a:avLst/>
+          </a:prstGeom>
+          <a:ln w="25400">
+            <a:solidFill>
+              <a:srgbClr val="DC143C"/>
+            </a:solidFill>
+            <a:prstDash val="solid"/>
+          </a:ln>
+        </p:spPr>
+        <p:style>
+          <a:lnRef idx="2">
+            <a:schemeClr val="accent1"/>
+          </a:lnRef>
+          <a:fillRef idx="0">
+            <a:schemeClr val="accent1"/>
+          </a:fillRef>
+          <a:effectRef idx="1">
+            <a:schemeClr val="accent1"/>
+          </a:effectRef>
+          <a:fontRef idx="minor">
+            <a:schemeClr val="tx1"/>
+          </a:fontRef>
+        </p:style>
+      </p:cxnSp>
+      <p:sp>
+        <p:nvSpPr>
+          <p:cNvPr id="4" name="TextBox 3"/>
+          <p:cNvSpPr txBox="1"/>
+          <p:nvPr/>
+        </p:nvSpPr>
+        <p:spPr>
+          <a:xfrm>
+            <a:off x="281443" y="838200"/>
+            <a:ext cx="513282" cy="276999"/>
+          </a:xfrm>
+          <a:prstGeom prst="rect">
+            <a:avLst/>
+          </a:prstGeom>
+          <a:noFill/>
+        </p:spPr>
+        <p:txBody>
+          <a:bodyPr wrap="none">
+            <a:spAutoFit/>
+          </a:bodyPr>
+          <a:lstStyle/>
+          <a:p>
+            <a:r>
+              <a:rPr sz="1200" b="1" dirty="0">
+                <a:solidFill>
+                  <a:srgbClr val="DC143C"/>
+                </a:solidFill>
+                <a:latin typeface="Comic Sans MS" panose="030F0902030302020204" pitchFamily="66" charset="0"/>
+              </a:rPr>
+              <a:t>main</a:t>
+            </a:r>
+          </a:p>
+        </p:txBody>
+      </p:sp>
+      <p:sp>
+        <p:nvSpPr>
+          <p:cNvPr id="5" name="Oval 4"/>
+          <p:cNvSpPr/>
+          <p:nvPr/>
+        </p:nvSpPr>
+        <p:spPr>
+          <a:xfrm>
+            <a:off x="1865495" y="848031"/>
+            <a:ext cx="127000" cy="127000"/>
+          </a:xfrm>
+          <a:prstGeom prst="ellipse">
+            <a:avLst/>
+          </a:prstGeom>
+          <a:solidFill>
+            <a:srgbClr val="DC143C"/>
+          </a:solidFill>
+          <a:ln>
+            <a:solidFill>
+              <a:srgbClr val="DC143C"/>
+            </a:solidFill>
+          </a:ln>
+        </p:spPr>
+        <p:style>
+          <a:lnRef idx="1">
+            <a:schemeClr val="accent1"/>
+          </a:lnRef>
+          <a:fillRef idx="3">
+            <a:schemeClr val="accent1"/>
+          </a:fillRef>
+          <a:effectRef idx="2">
+            <a:schemeClr val="accent1"/>
+          </a:effectRef>
+          <a:fontRef idx="minor">
+            <a:schemeClr val="lt1"/>
+          </a:fontRef>
+        </p:style>
+        <p:txBody>
+          <a:bodyPr rtlCol="0" anchor="ctr"/>
+          <a:lstStyle/>
+          <a:p>
+            <a:pPr algn="ctr"/>
+            <a:endParaRPr>
+              <a:latin typeface="Comic Sans MS" panose="030F0902030302020204" pitchFamily="66" charset="0"/>
+            </a:endParaRPr>
+          </a:p>
+        </p:txBody>
+      </p:sp>
+      <p:cxnSp>
+        <p:nvCxnSpPr>
+          <p:cNvPr id="11" name="Connector 10"/>
+          <p:cNvCxnSpPr/>
+          <p:nvPr/>
+        </p:nvCxnSpPr>
+        <p:spPr>
+          <a:xfrm>
+            <a:off x="1591291" y="1645920"/>
+            <a:ext cx="7315200" cy="0"/>
+          </a:xfrm>
+          <a:prstGeom prst="line">
+            <a:avLst/>
+          </a:prstGeom>
+          <a:ln w="25400">
+            <a:solidFill>
+              <a:srgbClr val="1E90FF"/>
+            </a:solidFill>
+            <a:prstDash val="solid"/>
+          </a:ln>
+        </p:spPr>
+        <p:style>
+          <a:lnRef idx="2">
+            <a:schemeClr val="accent1"/>
+          </a:lnRef>
+          <a:fillRef idx="0">
+            <a:schemeClr val="accent1"/>
+          </a:fillRef>
+          <a:effectRef idx="1">
+            <a:schemeClr val="accent1"/>
+          </a:effectRef>
+          <a:fontRef idx="minor">
+            <a:schemeClr val="tx1"/>
+          </a:fontRef>
+        </p:style>
+      </p:cxnSp>
+      <p:sp>
+        <p:nvSpPr>
+          <p:cNvPr id="12" name="TextBox 11"/>
+          <p:cNvSpPr txBox="1"/>
+          <p:nvPr/>
+        </p:nvSpPr>
+        <p:spPr>
+          <a:xfrm>
+            <a:off x="281443" y="1645922"/>
+            <a:ext cx="1290738" cy="276999"/>
+          </a:xfrm>
+          <a:prstGeom prst="rect">
+            <a:avLst/>
+          </a:prstGeom>
+          <a:noFill/>
+        </p:spPr>
+        <p:txBody>
+          <a:bodyPr wrap="none">
+            <a:spAutoFit/>
+          </a:bodyPr>
+          <a:lstStyle/>
+          <a:p>
+            <a:r>
+              <a:rPr sz="1200" b="1" dirty="0">
+                <a:solidFill>
+                  <a:srgbClr val="1E90FF"/>
+                </a:solidFill>
+                <a:latin typeface="Comic Sans MS" panose="030F0902030302020204" pitchFamily="66" charset="0"/>
+              </a:rPr>
+              <a:t>de</a:t>
+            </a:r>
+            <a:r>
+              <a:rPr lang="es-ES" sz="1200" b="1" dirty="0">
+                <a:solidFill>
+                  <a:srgbClr val="1E90FF"/>
+                </a:solidFill>
+                <a:latin typeface="Comic Sans MS" panose="030F0902030302020204" pitchFamily="66" charset="0"/>
+              </a:rPr>
+              <a:t>sarrollo2025</a:t>
+            </a:r>
+            <a:endParaRPr sz="1200" b="1" dirty="0">
+              <a:solidFill>
+                <a:srgbClr val="1E90FF"/>
+              </a:solidFill>
+              <a:latin typeface="Comic Sans MS" panose="030F0902030302020204" pitchFamily="66" charset="0"/>
+            </a:endParaRPr>
+          </a:p>
+        </p:txBody>
+      </p:sp>
+      <p:cxnSp>
+        <p:nvCxnSpPr>
+          <p:cNvPr id="19" name="Connector 18"/>
+          <p:cNvCxnSpPr/>
+          <p:nvPr/>
+        </p:nvCxnSpPr>
+        <p:spPr>
+          <a:xfrm>
+            <a:off x="1104403" y="3469965"/>
+            <a:ext cx="7315200" cy="0"/>
+          </a:xfrm>
+          <a:prstGeom prst="line">
+            <a:avLst/>
+          </a:prstGeom>
+          <a:ln w="25400">
+            <a:solidFill>
+              <a:srgbClr val="228B22"/>
+            </a:solidFill>
+            <a:prstDash val="solid"/>
+          </a:ln>
+        </p:spPr>
+        <p:style>
+          <a:lnRef idx="2">
+            <a:schemeClr val="accent1"/>
+          </a:lnRef>
+          <a:fillRef idx="0">
+            <a:schemeClr val="accent1"/>
+          </a:fillRef>
+          <a:effectRef idx="1">
+            <a:schemeClr val="accent1"/>
+          </a:effectRef>
+          <a:fontRef idx="minor">
+            <a:schemeClr val="tx1"/>
+          </a:fontRef>
+        </p:style>
+      </p:cxnSp>
+      <p:sp>
+        <p:nvSpPr>
+          <p:cNvPr id="20" name="TextBox 19"/>
+          <p:cNvSpPr txBox="1"/>
+          <p:nvPr/>
+        </p:nvSpPr>
+        <p:spPr>
+          <a:xfrm>
+            <a:off x="281443" y="3459081"/>
+            <a:ext cx="1098378" cy="276999"/>
+          </a:xfrm>
+          <a:prstGeom prst="rect">
+            <a:avLst/>
+          </a:prstGeom>
+          <a:noFill/>
+        </p:spPr>
+        <p:txBody>
+          <a:bodyPr wrap="none">
+            <a:spAutoFit/>
+          </a:bodyPr>
+          <a:lstStyle/>
+          <a:p>
+            <a:r>
+              <a:rPr sz="1200" b="1" dirty="0">
+                <a:solidFill>
+                  <a:srgbClr val="228B22"/>
+                </a:solidFill>
+                <a:latin typeface="Comic Sans MS" panose="030F0902030302020204" pitchFamily="66" charset="0"/>
+              </a:rPr>
+              <a:t>release</a:t>
+            </a:r>
+            <a:r>
+              <a:rPr lang="es-ES" sz="1200" b="1" dirty="0">
+                <a:solidFill>
+                  <a:srgbClr val="228B22"/>
+                </a:solidFill>
+                <a:latin typeface="Comic Sans MS" panose="030F0902030302020204" pitchFamily="66" charset="0"/>
+              </a:rPr>
+              <a:t>2025</a:t>
+            </a:r>
+            <a:endParaRPr sz="1200" b="1" dirty="0">
+              <a:solidFill>
+                <a:srgbClr val="228B22"/>
+              </a:solidFill>
+              <a:latin typeface="Comic Sans MS" panose="030F0902030302020204" pitchFamily="66" charset="0"/>
+            </a:endParaRPr>
+          </a:p>
+        </p:txBody>
+      </p:sp>
+      <p:sp>
+        <p:nvSpPr>
+          <p:cNvPr id="21" name="Oval 20"/>
+          <p:cNvSpPr/>
+          <p:nvPr/>
+        </p:nvSpPr>
+        <p:spPr>
+          <a:xfrm>
+            <a:off x="1962738" y="3367349"/>
+            <a:ext cx="127000" cy="127000"/>
+          </a:xfrm>
+          <a:prstGeom prst="ellipse">
+            <a:avLst/>
+          </a:prstGeom>
+          <a:solidFill>
+            <a:srgbClr val="228B22"/>
+          </a:solidFill>
+          <a:ln>
+            <a:solidFill>
+              <a:srgbClr val="228B22"/>
+            </a:solidFill>
+          </a:ln>
+        </p:spPr>
+        <p:style>
+          <a:lnRef idx="1">
+            <a:schemeClr val="accent1"/>
+          </a:lnRef>
+          <a:fillRef idx="3">
+            <a:schemeClr val="accent1"/>
+          </a:fillRef>
+          <a:effectRef idx="2">
+            <a:schemeClr val="accent1"/>
+          </a:effectRef>
+          <a:fontRef idx="minor">
+            <a:schemeClr val="lt1"/>
+          </a:fontRef>
+        </p:style>
+        <p:txBody>
+          <a:bodyPr rtlCol="0" anchor="ctr"/>
+          <a:lstStyle/>
+          <a:p>
+            <a:pPr algn="ctr"/>
+            <a:endParaRPr>
+              <a:latin typeface="Comic Sans MS" panose="030F0902030302020204" pitchFamily="66" charset="0"/>
+            </a:endParaRPr>
+          </a:p>
+        </p:txBody>
+      </p:sp>
+      <p:cxnSp>
+        <p:nvCxnSpPr>
+          <p:cNvPr id="27" name="Connector 26"/>
+          <p:cNvCxnSpPr/>
+          <p:nvPr/>
+        </p:nvCxnSpPr>
+        <p:spPr>
+          <a:xfrm>
+            <a:off x="1104403" y="4270758"/>
+            <a:ext cx="7315200" cy="0"/>
+          </a:xfrm>
+          <a:prstGeom prst="line">
+            <a:avLst/>
+          </a:prstGeom>
+          <a:ln w="25400">
+            <a:solidFill>
+              <a:srgbClr val="FF8C00"/>
+            </a:solidFill>
+            <a:prstDash val="solid"/>
+          </a:ln>
+        </p:spPr>
+        <p:style>
+          <a:lnRef idx="2">
+            <a:schemeClr val="accent1"/>
+          </a:lnRef>
+          <a:fillRef idx="0">
+            <a:schemeClr val="accent1"/>
+          </a:fillRef>
+          <a:effectRef idx="1">
+            <a:schemeClr val="accent1"/>
+          </a:effectRef>
+          <a:fontRef idx="minor">
+            <a:schemeClr val="tx1"/>
+          </a:fontRef>
+        </p:style>
+      </p:cxnSp>
+      <p:sp>
+        <p:nvSpPr>
+          <p:cNvPr id="28" name="TextBox 27"/>
+          <p:cNvSpPr txBox="1"/>
+          <p:nvPr/>
+        </p:nvSpPr>
+        <p:spPr>
+          <a:xfrm>
+            <a:off x="281443" y="4293592"/>
+            <a:ext cx="1207382" cy="276999"/>
+          </a:xfrm>
+          <a:prstGeom prst="rect">
+            <a:avLst/>
+          </a:prstGeom>
+          <a:noFill/>
+        </p:spPr>
+        <p:txBody>
+          <a:bodyPr wrap="none">
+            <a:spAutoFit/>
+          </a:bodyPr>
+          <a:lstStyle/>
+          <a:p>
+            <a:r>
+              <a:rPr sz="1200" b="1" dirty="0">
+                <a:solidFill>
+                  <a:srgbClr val="FF8C00"/>
+                </a:solidFill>
+                <a:latin typeface="Comic Sans MS" panose="030F0902030302020204" pitchFamily="66" charset="0"/>
+              </a:rPr>
+              <a:t>feature/alpha</a:t>
+            </a:r>
+          </a:p>
+        </p:txBody>
+      </p:sp>
+      <p:sp>
+        <p:nvSpPr>
+          <p:cNvPr id="29" name="Oval 28"/>
+          <p:cNvSpPr/>
+          <p:nvPr/>
+        </p:nvSpPr>
+        <p:spPr>
+          <a:xfrm>
+            <a:off x="1955303" y="4207258"/>
+            <a:ext cx="127000" cy="127000"/>
+          </a:xfrm>
+          <a:prstGeom prst="ellipse">
+            <a:avLst/>
+          </a:prstGeom>
+          <a:solidFill>
+            <a:srgbClr val="FF8C00"/>
+          </a:solidFill>
+          <a:ln>
+            <a:solidFill>
+              <a:srgbClr val="FF8C00"/>
+            </a:solidFill>
+          </a:ln>
+        </p:spPr>
+        <p:style>
+          <a:lnRef idx="1">
+            <a:schemeClr val="accent1"/>
+          </a:lnRef>
+          <a:fillRef idx="3">
+            <a:schemeClr val="accent1"/>
+          </a:fillRef>
+          <a:effectRef idx="2">
+            <a:schemeClr val="accent1"/>
+          </a:effectRef>
+          <a:fontRef idx="minor">
+            <a:schemeClr val="lt1"/>
+          </a:fontRef>
+        </p:style>
+        <p:txBody>
+          <a:bodyPr rtlCol="0" anchor="ctr"/>
+          <a:lstStyle/>
+          <a:p>
+            <a:pPr algn="ctr"/>
+            <a:endParaRPr>
+              <a:latin typeface="Comic Sans MS" panose="030F0902030302020204" pitchFamily="66" charset="0"/>
+            </a:endParaRPr>
+          </a:p>
+        </p:txBody>
+      </p:sp>
+      <p:cxnSp>
+        <p:nvCxnSpPr>
+          <p:cNvPr id="35" name="Connector 34"/>
+          <p:cNvCxnSpPr/>
+          <p:nvPr/>
+        </p:nvCxnSpPr>
+        <p:spPr>
+          <a:xfrm>
+            <a:off x="1104403" y="5002278"/>
+            <a:ext cx="7315200" cy="0"/>
+          </a:xfrm>
+          <a:prstGeom prst="line">
+            <a:avLst/>
+          </a:prstGeom>
+          <a:ln w="25400">
+            <a:solidFill>
+              <a:srgbClr val="9400D3"/>
+            </a:solidFill>
+            <a:prstDash val="solid"/>
+          </a:ln>
+        </p:spPr>
+        <p:style>
+          <a:lnRef idx="2">
+            <a:schemeClr val="accent1"/>
+          </a:lnRef>
+          <a:fillRef idx="0">
+            <a:schemeClr val="accent1"/>
+          </a:fillRef>
+          <a:effectRef idx="1">
+            <a:schemeClr val="accent1"/>
+          </a:effectRef>
+          <a:fontRef idx="minor">
+            <a:schemeClr val="tx1"/>
+          </a:fontRef>
+        </p:style>
+      </p:cxnSp>
+      <p:sp>
+        <p:nvSpPr>
+          <p:cNvPr id="36" name="TextBox 35"/>
+          <p:cNvSpPr txBox="1"/>
+          <p:nvPr/>
+        </p:nvSpPr>
+        <p:spPr>
+          <a:xfrm>
+            <a:off x="281443" y="4981833"/>
+            <a:ext cx="1160895" cy="276999"/>
+          </a:xfrm>
+          <a:prstGeom prst="rect">
+            <a:avLst/>
+          </a:prstGeom>
+          <a:noFill/>
+        </p:spPr>
+        <p:txBody>
+          <a:bodyPr wrap="none">
+            <a:spAutoFit/>
+          </a:bodyPr>
+          <a:lstStyle/>
+          <a:p>
+            <a:r>
+              <a:rPr sz="1200" b="1">
+                <a:solidFill>
+                  <a:srgbClr val="9400D3"/>
+                </a:solidFill>
+                <a:latin typeface="Comic Sans MS" panose="030F0902030302020204" pitchFamily="66" charset="0"/>
+              </a:rPr>
+              <a:t>feature/beta</a:t>
+            </a:r>
+          </a:p>
+        </p:txBody>
+      </p:sp>
+      <p:sp>
+        <p:nvSpPr>
+          <p:cNvPr id="37" name="Oval 36"/>
+          <p:cNvSpPr/>
+          <p:nvPr/>
+        </p:nvSpPr>
+        <p:spPr>
+          <a:xfrm>
+            <a:off x="1944031" y="4972466"/>
+            <a:ext cx="127000" cy="127000"/>
+          </a:xfrm>
+          <a:prstGeom prst="ellipse">
+            <a:avLst/>
+          </a:prstGeom>
+          <a:solidFill>
+            <a:srgbClr val="9400D3"/>
+          </a:solidFill>
+          <a:ln>
+            <a:solidFill>
+              <a:srgbClr val="9400D3"/>
+            </a:solidFill>
+          </a:ln>
+        </p:spPr>
+        <p:style>
+          <a:lnRef idx="1">
+            <a:schemeClr val="accent1"/>
+          </a:lnRef>
+          <a:fillRef idx="3">
+            <a:schemeClr val="accent1"/>
+          </a:fillRef>
+          <a:effectRef idx="2">
+            <a:schemeClr val="accent1"/>
+          </a:effectRef>
+          <a:fontRef idx="minor">
+            <a:schemeClr val="lt1"/>
+          </a:fontRef>
+        </p:style>
+        <p:txBody>
+          <a:bodyPr rtlCol="0" anchor="ctr"/>
+          <a:lstStyle/>
+          <a:p>
+            <a:pPr algn="ctr"/>
+            <a:endParaRPr>
+              <a:latin typeface="Comic Sans MS" panose="030F0902030302020204" pitchFamily="66" charset="0"/>
+            </a:endParaRPr>
+          </a:p>
+        </p:txBody>
+      </p:sp>
+      <p:cxnSp>
+        <p:nvCxnSpPr>
+          <p:cNvPr id="43" name="Connector 42"/>
+          <p:cNvCxnSpPr/>
+          <p:nvPr/>
+        </p:nvCxnSpPr>
+        <p:spPr>
+          <a:xfrm>
+            <a:off x="1104403" y="5733798"/>
+            <a:ext cx="7315200" cy="0"/>
+          </a:xfrm>
+          <a:prstGeom prst="line">
+            <a:avLst/>
+          </a:prstGeom>
+          <a:ln w="25400">
+            <a:solidFill>
+              <a:srgbClr val="00CED1"/>
+            </a:solidFill>
+            <a:prstDash val="solid"/>
+          </a:ln>
+        </p:spPr>
+        <p:style>
+          <a:lnRef idx="2">
+            <a:schemeClr val="accent1"/>
+          </a:lnRef>
+          <a:fillRef idx="0">
+            <a:schemeClr val="accent1"/>
+          </a:fillRef>
+          <a:effectRef idx="1">
+            <a:schemeClr val="accent1"/>
+          </a:effectRef>
+          <a:fontRef idx="minor">
+            <a:schemeClr val="tx1"/>
+          </a:fontRef>
+        </p:style>
+      </p:cxnSp>
+      <p:sp>
+        <p:nvSpPr>
+          <p:cNvPr id="44" name="TextBox 43"/>
+          <p:cNvSpPr txBox="1"/>
+          <p:nvPr/>
+        </p:nvSpPr>
+        <p:spPr>
+          <a:xfrm>
+            <a:off x="281443" y="5713353"/>
+            <a:ext cx="1317990" cy="276999"/>
+          </a:xfrm>
+          <a:prstGeom prst="rect">
+            <a:avLst/>
+          </a:prstGeom>
+          <a:noFill/>
+        </p:spPr>
+        <p:txBody>
+          <a:bodyPr wrap="none">
+            <a:spAutoFit/>
+          </a:bodyPr>
+          <a:lstStyle/>
+          <a:p>
+            <a:r>
+              <a:rPr sz="1200" b="1">
+                <a:solidFill>
+                  <a:srgbClr val="00CED1"/>
+                </a:solidFill>
+                <a:latin typeface="Comic Sans MS" panose="030F0902030302020204" pitchFamily="66" charset="0"/>
+              </a:rPr>
+              <a:t>feature/gamma</a:t>
+            </a:r>
+          </a:p>
+        </p:txBody>
+      </p:sp>
+      <p:sp>
+        <p:nvSpPr>
+          <p:cNvPr id="45" name="Oval 44"/>
+          <p:cNvSpPr/>
+          <p:nvPr/>
+        </p:nvSpPr>
+        <p:spPr>
+          <a:xfrm>
+            <a:off x="1962738" y="5703985"/>
+            <a:ext cx="127000" cy="127000"/>
+          </a:xfrm>
+          <a:prstGeom prst="ellipse">
+            <a:avLst/>
+          </a:prstGeom>
+          <a:solidFill>
+            <a:srgbClr val="00CED1"/>
+          </a:solidFill>
+          <a:ln>
+            <a:solidFill>
+              <a:srgbClr val="00CED1"/>
+            </a:solidFill>
+          </a:ln>
+        </p:spPr>
+        <p:style>
+          <a:lnRef idx="1">
+            <a:schemeClr val="accent1"/>
+          </a:lnRef>
+          <a:fillRef idx="3">
+            <a:schemeClr val="accent1"/>
+          </a:fillRef>
+          <a:effectRef idx="2">
+            <a:schemeClr val="accent1"/>
+          </a:effectRef>
+          <a:fontRef idx="minor">
+            <a:schemeClr val="lt1"/>
+          </a:fontRef>
+        </p:style>
+        <p:txBody>
+          <a:bodyPr rtlCol="0" anchor="ctr"/>
+          <a:lstStyle/>
+          <a:p>
+            <a:pPr algn="ctr"/>
+            <a:endParaRPr>
+              <a:latin typeface="Comic Sans MS" panose="030F0902030302020204" pitchFamily="66" charset="0"/>
+            </a:endParaRPr>
+          </a:p>
+        </p:txBody>
+      </p:sp>
+      <p:cxnSp>
+        <p:nvCxnSpPr>
+          <p:cNvPr id="57" name="Connector 10">
+            <a:extLst>
+              <a:ext uri="{FF2B5EF4-FFF2-40B4-BE49-F238E27FC236}">
+                <a16:creationId xmlns:a16="http://schemas.microsoft.com/office/drawing/2014/main" id="{CFD36013-5278-9540-9DF5-FA5F7C1B0164}"/>
+              </a:ext>
+            </a:extLst>
+          </p:cNvPr>
+          <p:cNvCxnSpPr/>
+          <p:nvPr/>
+        </p:nvCxnSpPr>
+        <p:spPr>
+          <a:xfrm>
+            <a:off x="1543789" y="2463941"/>
+            <a:ext cx="7315200" cy="0"/>
+          </a:xfrm>
+          <a:prstGeom prst="line">
+            <a:avLst/>
+          </a:prstGeom>
+          <a:ln w="25400">
+            <a:solidFill>
+              <a:schemeClr val="bg2">
+                <a:lumMod val="50000"/>
+              </a:schemeClr>
+            </a:solidFill>
+            <a:prstDash val="solid"/>
+          </a:ln>
+        </p:spPr>
+        <p:style>
+          <a:lnRef idx="2">
+            <a:schemeClr val="accent1"/>
+          </a:lnRef>
+          <a:fillRef idx="0">
+            <a:schemeClr val="accent1"/>
+          </a:fillRef>
+          <a:effectRef idx="1">
+            <a:schemeClr val="accent1"/>
+          </a:effectRef>
+          <a:fontRef idx="minor">
+            <a:schemeClr val="tx1"/>
+          </a:fontRef>
+        </p:style>
+      </p:cxnSp>
+      <p:sp>
+        <p:nvSpPr>
+          <p:cNvPr id="58" name="TextBox 57">
+            <a:extLst>
+              <a:ext uri="{FF2B5EF4-FFF2-40B4-BE49-F238E27FC236}">
+                <a16:creationId xmlns:a16="http://schemas.microsoft.com/office/drawing/2014/main" id="{8AF659C3-70DE-FC40-A31A-D27D3F364B7C}"/>
+              </a:ext>
+            </a:extLst>
+          </p:cNvPr>
+          <p:cNvSpPr txBox="1"/>
+          <p:nvPr/>
+        </p:nvSpPr>
+        <p:spPr>
+          <a:xfrm>
+            <a:off x="281443" y="2463943"/>
+            <a:ext cx="1016625" cy="276999"/>
+          </a:xfrm>
+          <a:prstGeom prst="rect">
+            <a:avLst/>
+          </a:prstGeom>
+          <a:noFill/>
+        </p:spPr>
+        <p:txBody>
+          <a:bodyPr wrap="none">
+            <a:spAutoFit/>
+          </a:bodyPr>
+          <a:lstStyle/>
+          <a:p>
+            <a:r>
+              <a:rPr lang="es-ES" sz="1200" b="1" dirty="0">
+                <a:solidFill>
+                  <a:schemeClr val="bg2">
+                    <a:lumMod val="50000"/>
+                  </a:schemeClr>
+                </a:solidFill>
+                <a:latin typeface="Comic Sans MS" panose="030F0902030302020204" pitchFamily="66" charset="0"/>
+              </a:rPr>
+              <a:t>hotfix2025</a:t>
+            </a:r>
+            <a:endParaRPr sz="1200" b="1" dirty="0">
+              <a:solidFill>
+                <a:schemeClr val="bg2">
+                  <a:lumMod val="50000"/>
+                </a:schemeClr>
+              </a:solidFill>
+              <a:latin typeface="Comic Sans MS" panose="030F0902030302020204" pitchFamily="66" charset="0"/>
+            </a:endParaRPr>
+          </a:p>
+        </p:txBody>
+      </p:sp>
+      <p:sp>
+        <p:nvSpPr>
+          <p:cNvPr id="59" name="Oval 58">
+            <a:extLst>
+              <a:ext uri="{FF2B5EF4-FFF2-40B4-BE49-F238E27FC236}">
+                <a16:creationId xmlns:a16="http://schemas.microsoft.com/office/drawing/2014/main" id="{6963C570-E5C6-F947-B221-2C62F1B47564}"/>
+              </a:ext>
+            </a:extLst>
+          </p:cNvPr>
+          <p:cNvSpPr/>
+          <p:nvPr/>
+        </p:nvSpPr>
+        <p:spPr>
+          <a:xfrm>
+            <a:off x="1955303" y="2400441"/>
+            <a:ext cx="127000" cy="127000"/>
+          </a:xfrm>
+          <a:prstGeom prst="ellipse">
+            <a:avLst/>
+          </a:prstGeom>
+          <a:solidFill>
+            <a:schemeClr val="bg2">
+              <a:lumMod val="50000"/>
+            </a:schemeClr>
+          </a:solidFill>
+          <a:ln>
+            <a:solidFill>
+              <a:schemeClr val="bg2">
+                <a:lumMod val="50000"/>
+              </a:schemeClr>
+            </a:solidFill>
+          </a:ln>
+        </p:spPr>
+        <p:style>
+          <a:lnRef idx="1">
+            <a:schemeClr val="accent1"/>
+          </a:lnRef>
+          <a:fillRef idx="3">
+            <a:schemeClr val="accent1"/>
+          </a:fillRef>
+          <a:effectRef idx="2">
+            <a:schemeClr val="accent1"/>
+          </a:effectRef>
+          <a:fontRef idx="minor">
+            <a:schemeClr val="lt1"/>
+          </a:fontRef>
+        </p:style>
+        <p:txBody>
+          <a:bodyPr rtlCol="0" anchor="ctr"/>
+          <a:lstStyle/>
+          <a:p>
+            <a:pPr algn="ctr"/>
+            <a:endParaRPr>
+              <a:latin typeface="Comic Sans MS" panose="030F0902030302020204" pitchFamily="66" charset="0"/>
+            </a:endParaRPr>
+          </a:p>
+        </p:txBody>
+      </p:sp>
+      <p:sp>
+        <p:nvSpPr>
+          <p:cNvPr id="65" name="TextBox 64">
+            <a:extLst>
+              <a:ext uri="{FF2B5EF4-FFF2-40B4-BE49-F238E27FC236}">
+                <a16:creationId xmlns:a16="http://schemas.microsoft.com/office/drawing/2014/main" id="{83748316-7B92-AB41-B5B8-BBDA78992E82}"/>
+              </a:ext>
+            </a:extLst>
+          </p:cNvPr>
+          <p:cNvSpPr txBox="1"/>
+          <p:nvPr/>
+        </p:nvSpPr>
+        <p:spPr>
+          <a:xfrm>
+            <a:off x="8220213" y="136058"/>
+            <a:ext cx="798617" cy="369332"/>
+          </a:xfrm>
+          <a:prstGeom prst="rect">
+            <a:avLst/>
+          </a:prstGeom>
+          <a:noFill/>
+        </p:spPr>
+        <p:txBody>
+          <a:bodyPr wrap="none" rtlCol="0">
+            <a:spAutoFit/>
+          </a:bodyPr>
+          <a:lstStyle/>
+          <a:p>
+            <a:r>
+              <a:rPr lang="en-US" dirty="0" err="1">
+                <a:solidFill>
+                  <a:schemeClr val="accent1">
+                    <a:lumMod val="75000"/>
+                  </a:schemeClr>
+                </a:solidFill>
+                <a:latin typeface="Comic Sans MS" panose="030F0902030302020204" pitchFamily="66" charset="0"/>
+              </a:rPr>
+              <a:t>Pág</a:t>
+            </a:r>
+            <a:r>
+              <a:rPr lang="en-US" dirty="0">
+                <a:solidFill>
+                  <a:schemeClr val="accent1">
+                    <a:lumMod val="75000"/>
+                  </a:schemeClr>
+                </a:solidFill>
+                <a:latin typeface="Comic Sans MS" panose="030F0902030302020204" pitchFamily="66" charset="0"/>
+              </a:rPr>
+              <a:t>. I</a:t>
+            </a:r>
+          </a:p>
+        </p:txBody>
+      </p:sp>
+      <p:sp>
+        <p:nvSpPr>
+          <p:cNvPr id="67" name="Oval 66">
+            <a:extLst>
+              <a:ext uri="{FF2B5EF4-FFF2-40B4-BE49-F238E27FC236}">
+                <a16:creationId xmlns:a16="http://schemas.microsoft.com/office/drawing/2014/main" id="{8BAF2C6F-9C05-204D-8259-C8EB95D59A6F}"/>
+              </a:ext>
+            </a:extLst>
+          </p:cNvPr>
+          <p:cNvSpPr/>
+          <p:nvPr/>
+        </p:nvSpPr>
+        <p:spPr>
+          <a:xfrm>
+            <a:off x="1962738" y="1578704"/>
+            <a:ext cx="127000" cy="127000"/>
+          </a:xfrm>
+          <a:prstGeom prst="ellipse">
+            <a:avLst/>
+          </a:prstGeom>
+          <a:solidFill>
+            <a:srgbClr val="1E90FF"/>
+          </a:solidFill>
+          <a:ln>
+            <a:solidFill>
+              <a:srgbClr val="1E90FF"/>
+            </a:solidFill>
+          </a:ln>
+        </p:spPr>
+        <p:style>
+          <a:lnRef idx="1">
+            <a:schemeClr val="accent1"/>
+          </a:lnRef>
+          <a:fillRef idx="3">
+            <a:schemeClr val="accent1"/>
+          </a:fillRef>
+          <a:effectRef idx="2">
+            <a:schemeClr val="accent1"/>
+          </a:effectRef>
+          <a:fontRef idx="minor">
+            <a:schemeClr val="lt1"/>
+          </a:fontRef>
+        </p:style>
+        <p:txBody>
+          <a:bodyPr rtlCol="0" anchor="ctr"/>
+          <a:lstStyle/>
+          <a:p>
+            <a:pPr algn="ctr"/>
+            <a:endParaRPr>
+              <a:latin typeface="Comic Sans MS" panose="030F0902030302020204" pitchFamily="66" charset="0"/>
+            </a:endParaRPr>
+          </a:p>
+        </p:txBody>
+      </p:sp>
+      <p:sp>
+        <p:nvSpPr>
+          <p:cNvPr id="50" name="TextBox 49">
+            <a:extLst>
+              <a:ext uri="{FF2B5EF4-FFF2-40B4-BE49-F238E27FC236}">
+                <a16:creationId xmlns:a16="http://schemas.microsoft.com/office/drawing/2014/main" id="{5093DA87-72F5-F14F-97BF-C76E3A06E8CC}"/>
+              </a:ext>
+            </a:extLst>
+          </p:cNvPr>
+          <p:cNvSpPr txBox="1"/>
+          <p:nvPr/>
+        </p:nvSpPr>
+        <p:spPr>
+          <a:xfrm>
+            <a:off x="2046816" y="2018951"/>
+            <a:ext cx="1221809" cy="338554"/>
+          </a:xfrm>
+          <a:prstGeom prst="rect">
+            <a:avLst/>
+          </a:prstGeom>
+          <a:noFill/>
+          <a:ln>
+            <a:solidFill>
+              <a:schemeClr val="tx2"/>
+            </a:solidFill>
+          </a:ln>
+        </p:spPr>
+        <p:txBody>
+          <a:bodyPr wrap="none">
+            <a:spAutoFit/>
+          </a:bodyPr>
+          <a:lstStyle/>
+          <a:p>
+            <a:r>
+              <a:rPr lang="en-US" sz="800" dirty="0">
+                <a:solidFill>
+                  <a:schemeClr val="tx2">
+                    <a:lumMod val="60000"/>
+                    <a:lumOff val="40000"/>
+                  </a:schemeClr>
+                </a:solidFill>
+                <a:latin typeface="Comic Sans MS" panose="030F0902030302020204" pitchFamily="66" charset="0"/>
+              </a:rPr>
+              <a:t>tarea-202508221226</a:t>
+            </a:r>
+          </a:p>
+          <a:p>
+            <a:r>
+              <a:rPr lang="en-US" sz="800" dirty="0">
+                <a:solidFill>
+                  <a:schemeClr val="tx2">
+                    <a:lumMod val="60000"/>
+                    <a:lumOff val="40000"/>
+                  </a:schemeClr>
+                </a:solidFill>
+                <a:latin typeface="Comic Sans MS" panose="030F0902030302020204" pitchFamily="66" charset="0"/>
+              </a:rPr>
+              <a:t>21-08-2025</a:t>
+            </a:r>
+            <a:endParaRPr sz="800" dirty="0">
+              <a:solidFill>
+                <a:schemeClr val="tx2">
+                  <a:lumMod val="60000"/>
+                  <a:lumOff val="40000"/>
+                </a:schemeClr>
+              </a:solidFill>
+              <a:latin typeface="Comic Sans MS" panose="030F0902030302020204" pitchFamily="66" charset="0"/>
+            </a:endParaRPr>
+          </a:p>
+        </p:txBody>
+      </p:sp>
+      <p:cxnSp>
+        <p:nvCxnSpPr>
+          <p:cNvPr id="52" name="Connector 54">
+            <a:extLst>
+              <a:ext uri="{FF2B5EF4-FFF2-40B4-BE49-F238E27FC236}">
+                <a16:creationId xmlns:a16="http://schemas.microsoft.com/office/drawing/2014/main" id="{22ED9560-A71F-A842-989E-4BB1654165D1}"/>
+              </a:ext>
+            </a:extLst>
+          </p:cNvPr>
+          <p:cNvCxnSpPr>
+            <a:cxnSpLocks/>
+            <a:endCxn id="50" idx="2"/>
+          </p:cNvCxnSpPr>
+          <p:nvPr/>
+        </p:nvCxnSpPr>
+        <p:spPr>
+          <a:xfrm rot="5400000" flipH="1" flipV="1">
+            <a:off x="2270712" y="2457299"/>
+            <a:ext cx="486802" cy="287215"/>
+          </a:xfrm>
+          <a:prstGeom prst="bentConnector3">
+            <a:avLst/>
+          </a:prstGeom>
+          <a:ln w="19050">
+            <a:solidFill>
+              <a:srgbClr val="808080"/>
+            </a:solidFill>
+            <a:prstDash val="dash"/>
+          </a:ln>
+        </p:spPr>
+        <p:style>
+          <a:lnRef idx="2">
+            <a:schemeClr val="accent1"/>
+          </a:lnRef>
+          <a:fillRef idx="0">
+            <a:schemeClr val="accent1"/>
+          </a:fillRef>
+          <a:effectRef idx="1">
+            <a:schemeClr val="accent1"/>
+          </a:effectRef>
+          <a:fontRef idx="minor">
+            <a:schemeClr val="tx1"/>
+          </a:fontRef>
+        </p:style>
+      </p:cxnSp>
+      <p:sp>
+        <p:nvSpPr>
+          <p:cNvPr id="53" name="Oval 52">
+            <a:extLst>
+              <a:ext uri="{FF2B5EF4-FFF2-40B4-BE49-F238E27FC236}">
+                <a16:creationId xmlns:a16="http://schemas.microsoft.com/office/drawing/2014/main" id="{B2D245C5-1DBA-2246-956C-6182B1B60200}"/>
+              </a:ext>
+            </a:extLst>
+          </p:cNvPr>
+          <p:cNvSpPr/>
+          <p:nvPr/>
+        </p:nvSpPr>
+        <p:spPr>
+          <a:xfrm>
+            <a:off x="2385353" y="1573213"/>
+            <a:ext cx="127000" cy="127000"/>
+          </a:xfrm>
+          <a:prstGeom prst="ellipse">
+            <a:avLst/>
+          </a:prstGeom>
+          <a:solidFill>
+            <a:srgbClr val="1E90FF"/>
+          </a:solidFill>
+          <a:ln>
+            <a:solidFill>
+              <a:srgbClr val="1E90FF"/>
+            </a:solidFill>
+          </a:ln>
+        </p:spPr>
+        <p:style>
+          <a:lnRef idx="1">
+            <a:schemeClr val="accent1"/>
+          </a:lnRef>
+          <a:fillRef idx="3">
+            <a:schemeClr val="accent1"/>
+          </a:fillRef>
+          <a:effectRef idx="2">
+            <a:schemeClr val="accent1"/>
+          </a:effectRef>
+          <a:fontRef idx="minor">
+            <a:schemeClr val="lt1"/>
+          </a:fontRef>
+        </p:style>
+        <p:txBody>
+          <a:bodyPr rtlCol="0" anchor="ctr"/>
+          <a:lstStyle/>
+          <a:p>
+            <a:pPr algn="ctr"/>
+            <a:endParaRPr>
+              <a:latin typeface="Comic Sans MS" panose="030F0902030302020204" pitchFamily="66" charset="0"/>
+            </a:endParaRPr>
+          </a:p>
+        </p:txBody>
+      </p:sp>
+      <p:cxnSp>
+        <p:nvCxnSpPr>
+          <p:cNvPr id="54" name="Straight Arrow Connector 53">
+            <a:extLst>
+              <a:ext uri="{FF2B5EF4-FFF2-40B4-BE49-F238E27FC236}">
+                <a16:creationId xmlns:a16="http://schemas.microsoft.com/office/drawing/2014/main" id="{E72F2241-7356-554F-9FA8-A666F323C011}"/>
+              </a:ext>
+            </a:extLst>
+          </p:cNvPr>
+          <p:cNvCxnSpPr>
+            <a:cxnSpLocks/>
+            <a:stCxn id="53" idx="5"/>
+            <a:endCxn id="50" idx="0"/>
+          </p:cNvCxnSpPr>
+          <p:nvPr/>
+        </p:nvCxnSpPr>
+        <p:spPr>
+          <a:xfrm>
+            <a:off x="2493754" y="1681614"/>
+            <a:ext cx="163967" cy="337337"/>
+          </a:xfrm>
+          <a:prstGeom prst="straightConnector1">
+            <a:avLst/>
+          </a:prstGeom>
+          <a:ln>
+            <a:tailEnd type="triangle"/>
+          </a:ln>
+        </p:spPr>
+        <p:style>
+          <a:lnRef idx="2">
+            <a:schemeClr val="accent1"/>
+          </a:lnRef>
+          <a:fillRef idx="0">
+            <a:schemeClr val="accent1"/>
+          </a:fillRef>
+          <a:effectRef idx="1">
+            <a:schemeClr val="accent1"/>
+          </a:effectRef>
+          <a:fontRef idx="minor">
+            <a:schemeClr val="tx1"/>
+          </a:fontRef>
+        </p:style>
+      </p:cxnSp>
+      <p:sp>
+        <p:nvSpPr>
+          <p:cNvPr id="66" name="TextBox 65">
+            <a:extLst>
+              <a:ext uri="{FF2B5EF4-FFF2-40B4-BE49-F238E27FC236}">
+                <a16:creationId xmlns:a16="http://schemas.microsoft.com/office/drawing/2014/main" id="{87408CE6-E41B-804C-ABBC-4B97223A2433}"/>
+              </a:ext>
+            </a:extLst>
+          </p:cNvPr>
+          <p:cNvSpPr txBox="1"/>
+          <p:nvPr/>
+        </p:nvSpPr>
+        <p:spPr>
+          <a:xfrm>
+            <a:off x="2465842" y="4025331"/>
+            <a:ext cx="771365" cy="215444"/>
+          </a:xfrm>
+          <a:prstGeom prst="rect">
+            <a:avLst/>
+          </a:prstGeom>
+          <a:noFill/>
+        </p:spPr>
+        <p:txBody>
+          <a:bodyPr wrap="none" rtlCol="0">
+            <a:spAutoFit/>
+          </a:bodyPr>
+          <a:lstStyle/>
+          <a:p>
+            <a:r>
+              <a:rPr lang="en-US" sz="800" dirty="0">
+                <a:solidFill>
+                  <a:schemeClr val="accent6"/>
+                </a:solidFill>
+                <a:latin typeface="Comic Sans MS" panose="030F0902030302020204" pitchFamily="66" charset="0"/>
+              </a:rPr>
+              <a:t>22-08-2025</a:t>
+            </a:r>
+          </a:p>
+        </p:txBody>
+      </p:sp>
+      <p:sp>
+        <p:nvSpPr>
+          <p:cNvPr id="68" name="Oval 67">
+            <a:extLst>
+              <a:ext uri="{FF2B5EF4-FFF2-40B4-BE49-F238E27FC236}">
+                <a16:creationId xmlns:a16="http://schemas.microsoft.com/office/drawing/2014/main" id="{93254C3B-40CE-0A46-836B-194C397AF15B}"/>
+              </a:ext>
+            </a:extLst>
+          </p:cNvPr>
+          <p:cNvSpPr/>
+          <p:nvPr/>
+        </p:nvSpPr>
+        <p:spPr>
+          <a:xfrm>
+            <a:off x="2883587" y="1055555"/>
+            <a:ext cx="251999" cy="251999"/>
+          </a:xfrm>
+          <a:prstGeom prst="ellipse">
+            <a:avLst/>
+          </a:prstGeom>
+          <a:solidFill>
+            <a:srgbClr val="1E90FF"/>
+          </a:solidFill>
+          <a:ln>
+            <a:solidFill>
+              <a:srgbClr val="1E90FF"/>
+            </a:solidFill>
+          </a:ln>
+        </p:spPr>
+        <p:style>
+          <a:lnRef idx="1">
+            <a:schemeClr val="accent1"/>
+          </a:lnRef>
+          <a:fillRef idx="3">
+            <a:schemeClr val="accent1"/>
+          </a:fillRef>
+          <a:effectRef idx="2">
+            <a:schemeClr val="accent1"/>
+          </a:effectRef>
+          <a:fontRef idx="minor">
+            <a:schemeClr val="lt1"/>
+          </a:fontRef>
+        </p:style>
+        <p:txBody>
+          <a:bodyPr rtlCol="0" anchor="ctr"/>
+          <a:lstStyle/>
+          <a:p>
+            <a:pPr algn="ctr"/>
+            <a:r>
+              <a:rPr lang="es-ES" sz="1400" dirty="0">
+                <a:latin typeface="Comic Sans MS" panose="030F0902030302020204" pitchFamily="66" charset="0"/>
+              </a:rPr>
+              <a:t>C</a:t>
+            </a:r>
+            <a:endParaRPr sz="1400" dirty="0">
+              <a:latin typeface="Comic Sans MS" panose="030F0902030302020204" pitchFamily="66" charset="0"/>
+            </a:endParaRPr>
+          </a:p>
+        </p:txBody>
+      </p:sp>
+      <p:sp>
+        <p:nvSpPr>
+          <p:cNvPr id="69" name="Oval 68">
+            <a:extLst>
+              <a:ext uri="{FF2B5EF4-FFF2-40B4-BE49-F238E27FC236}">
+                <a16:creationId xmlns:a16="http://schemas.microsoft.com/office/drawing/2014/main" id="{B15F1637-6D4F-6E4A-B808-1FACDCF43E9C}"/>
+              </a:ext>
+            </a:extLst>
+          </p:cNvPr>
+          <p:cNvSpPr/>
+          <p:nvPr/>
+        </p:nvSpPr>
+        <p:spPr>
+          <a:xfrm>
+            <a:off x="2900114" y="1338565"/>
+            <a:ext cx="251999" cy="251999"/>
+          </a:xfrm>
+          <a:prstGeom prst="ellipse">
+            <a:avLst/>
+          </a:prstGeom>
+          <a:solidFill>
+            <a:srgbClr val="1E90FF"/>
+          </a:solidFill>
+          <a:ln>
+            <a:solidFill>
+              <a:srgbClr val="1E90FF"/>
+            </a:solidFill>
+          </a:ln>
+        </p:spPr>
+        <p:style>
+          <a:lnRef idx="1">
+            <a:schemeClr val="accent1"/>
+          </a:lnRef>
+          <a:fillRef idx="3">
+            <a:schemeClr val="accent1"/>
+          </a:fillRef>
+          <a:effectRef idx="2">
+            <a:schemeClr val="accent1"/>
+          </a:effectRef>
+          <a:fontRef idx="minor">
+            <a:schemeClr val="lt1"/>
+          </a:fontRef>
+        </p:style>
+        <p:txBody>
+          <a:bodyPr rtlCol="0" anchor="ctr"/>
+          <a:lstStyle/>
+          <a:p>
+            <a:pPr algn="ctr"/>
+            <a:r>
+              <a:rPr lang="es-ES" sz="1400" dirty="0">
+                <a:latin typeface="Comic Sans MS" panose="030F0902030302020204" pitchFamily="66" charset="0"/>
+              </a:rPr>
+              <a:t>P</a:t>
+            </a:r>
+            <a:endParaRPr sz="1400" dirty="0">
+              <a:latin typeface="Comic Sans MS" panose="030F0902030302020204" pitchFamily="66" charset="0"/>
+            </a:endParaRPr>
+          </a:p>
+        </p:txBody>
+      </p:sp>
+      <p:cxnSp>
+        <p:nvCxnSpPr>
+          <p:cNvPr id="70" name="Straight Connector 69">
+            <a:extLst>
+              <a:ext uri="{FF2B5EF4-FFF2-40B4-BE49-F238E27FC236}">
+                <a16:creationId xmlns:a16="http://schemas.microsoft.com/office/drawing/2014/main" id="{6F34863C-681B-5548-91BC-3E8F506B1653}"/>
+              </a:ext>
+            </a:extLst>
+          </p:cNvPr>
+          <p:cNvCxnSpPr>
+            <a:cxnSpLocks/>
+            <a:stCxn id="68" idx="2"/>
+            <a:endCxn id="53" idx="0"/>
+          </p:cNvCxnSpPr>
+          <p:nvPr/>
+        </p:nvCxnSpPr>
+        <p:spPr>
+          <a:xfrm flipH="1">
+            <a:off x="2448853" y="1181555"/>
+            <a:ext cx="434734" cy="391658"/>
+          </a:xfrm>
+          <a:prstGeom prst="line">
+            <a:avLst/>
+          </a:prstGeom>
+        </p:spPr>
+        <p:style>
+          <a:lnRef idx="2">
+            <a:schemeClr val="accent1"/>
+          </a:lnRef>
+          <a:fillRef idx="0">
+            <a:schemeClr val="accent1"/>
+          </a:fillRef>
+          <a:effectRef idx="1">
+            <a:schemeClr val="accent1"/>
+          </a:effectRef>
+          <a:fontRef idx="minor">
+            <a:schemeClr val="tx1"/>
+          </a:fontRef>
+        </p:style>
+      </p:cxnSp>
+      <p:cxnSp>
+        <p:nvCxnSpPr>
+          <p:cNvPr id="71" name="Straight Connector 70">
+            <a:extLst>
+              <a:ext uri="{FF2B5EF4-FFF2-40B4-BE49-F238E27FC236}">
+                <a16:creationId xmlns:a16="http://schemas.microsoft.com/office/drawing/2014/main" id="{C6F4ACCE-CE9A-8740-804F-4A383AE95AE7}"/>
+              </a:ext>
+            </a:extLst>
+          </p:cNvPr>
+          <p:cNvCxnSpPr>
+            <a:cxnSpLocks/>
+            <a:stCxn id="69" idx="4"/>
+            <a:endCxn id="53" idx="6"/>
+          </p:cNvCxnSpPr>
+          <p:nvPr/>
+        </p:nvCxnSpPr>
+        <p:spPr>
+          <a:xfrm flipH="1">
+            <a:off x="2512353" y="1590564"/>
+            <a:ext cx="513761" cy="46149"/>
+          </a:xfrm>
+          <a:prstGeom prst="line">
+            <a:avLst/>
+          </a:prstGeom>
+        </p:spPr>
+        <p:style>
+          <a:lnRef idx="2">
+            <a:schemeClr val="accent1"/>
+          </a:lnRef>
+          <a:fillRef idx="0">
+            <a:schemeClr val="accent1"/>
+          </a:fillRef>
+          <a:effectRef idx="1">
+            <a:schemeClr val="accent1"/>
+          </a:effectRef>
+          <a:fontRef idx="minor">
+            <a:schemeClr val="tx1"/>
+          </a:fontRef>
+        </p:style>
+      </p:cxnSp>
+      <p:sp>
+        <p:nvSpPr>
+          <p:cNvPr id="72" name="TextBox 71">
+            <a:extLst>
+              <a:ext uri="{FF2B5EF4-FFF2-40B4-BE49-F238E27FC236}">
+                <a16:creationId xmlns:a16="http://schemas.microsoft.com/office/drawing/2014/main" id="{785DDFD7-2438-7647-8CC7-EF209C12C1AA}"/>
+              </a:ext>
+            </a:extLst>
+          </p:cNvPr>
+          <p:cNvSpPr txBox="1"/>
+          <p:nvPr/>
+        </p:nvSpPr>
+        <p:spPr>
+          <a:xfrm>
+            <a:off x="1817902" y="2855389"/>
+            <a:ext cx="1824538" cy="230832"/>
+          </a:xfrm>
+          <a:prstGeom prst="rect">
+            <a:avLst/>
+          </a:prstGeom>
+          <a:noFill/>
+        </p:spPr>
+        <p:txBody>
+          <a:bodyPr wrap="none">
+            <a:spAutoFit/>
+          </a:bodyPr>
+          <a:lstStyle/>
+          <a:p>
+            <a:r>
+              <a:rPr lang="es-ES" sz="900" dirty="0" err="1">
+                <a:solidFill>
+                  <a:srgbClr val="505050"/>
+                </a:solidFill>
+                <a:latin typeface="Comic Sans MS" panose="030F0902030302020204" pitchFamily="66" charset="0"/>
+              </a:rPr>
+              <a:t>feature</a:t>
+            </a:r>
+            <a:r>
+              <a:rPr lang="es-ES" sz="900" dirty="0">
+                <a:solidFill>
+                  <a:srgbClr val="505050"/>
+                </a:solidFill>
+                <a:latin typeface="Comic Sans MS" panose="030F0902030302020204" pitchFamily="66" charset="0"/>
+              </a:rPr>
+              <a:t>/tarea-202508221226</a:t>
+            </a:r>
+            <a:endParaRPr sz="900" dirty="0">
+              <a:solidFill>
+                <a:srgbClr val="505050"/>
+              </a:solidFill>
+              <a:latin typeface="Comic Sans MS" panose="030F0902030302020204" pitchFamily="66" charset="0"/>
+            </a:endParaRPr>
+          </a:p>
+        </p:txBody>
+      </p:sp>
+      <p:sp>
+        <p:nvSpPr>
+          <p:cNvPr id="75" name="TextBox 74">
+            <a:extLst>
+              <a:ext uri="{FF2B5EF4-FFF2-40B4-BE49-F238E27FC236}">
+                <a16:creationId xmlns:a16="http://schemas.microsoft.com/office/drawing/2014/main" id="{26C1C14F-EC62-1A41-907D-3968BEC71269}"/>
+              </a:ext>
+            </a:extLst>
+          </p:cNvPr>
+          <p:cNvSpPr txBox="1"/>
+          <p:nvPr/>
+        </p:nvSpPr>
+        <p:spPr>
+          <a:xfrm>
+            <a:off x="3120653" y="1075603"/>
+            <a:ext cx="755335" cy="215444"/>
+          </a:xfrm>
+          <a:prstGeom prst="rect">
+            <a:avLst/>
+          </a:prstGeom>
+          <a:noFill/>
+        </p:spPr>
+        <p:txBody>
+          <a:bodyPr wrap="none" rtlCol="0">
+            <a:spAutoFit/>
+          </a:bodyPr>
+          <a:lstStyle/>
+          <a:p>
+            <a:r>
+              <a:rPr lang="en-US" sz="800" dirty="0">
+                <a:solidFill>
+                  <a:schemeClr val="tx2">
+                    <a:lumMod val="60000"/>
+                    <a:lumOff val="40000"/>
+                  </a:schemeClr>
+                </a:solidFill>
+                <a:latin typeface="Comic Sans MS" panose="030F0902030302020204" pitchFamily="66" charset="0"/>
+              </a:rPr>
+              <a:t>21-08-2025</a:t>
+            </a:r>
+          </a:p>
+        </p:txBody>
+      </p:sp>
+      <p:sp>
+        <p:nvSpPr>
+          <p:cNvPr id="76" name="TextBox 75">
+            <a:extLst>
+              <a:ext uri="{FF2B5EF4-FFF2-40B4-BE49-F238E27FC236}">
+                <a16:creationId xmlns:a16="http://schemas.microsoft.com/office/drawing/2014/main" id="{71F51E49-6E85-7F47-B222-C89BFB511E24}"/>
+              </a:ext>
+            </a:extLst>
+          </p:cNvPr>
+          <p:cNvSpPr txBox="1"/>
+          <p:nvPr/>
+        </p:nvSpPr>
+        <p:spPr>
+          <a:xfrm>
+            <a:off x="3187367" y="1394497"/>
+            <a:ext cx="755335" cy="215444"/>
+          </a:xfrm>
+          <a:prstGeom prst="rect">
+            <a:avLst/>
+          </a:prstGeom>
+          <a:noFill/>
+        </p:spPr>
+        <p:txBody>
+          <a:bodyPr wrap="none" rtlCol="0">
+            <a:spAutoFit/>
+          </a:bodyPr>
+          <a:lstStyle/>
+          <a:p>
+            <a:r>
+              <a:rPr lang="en-US" sz="800" dirty="0">
+                <a:solidFill>
+                  <a:schemeClr val="tx2">
+                    <a:lumMod val="60000"/>
+                    <a:lumOff val="40000"/>
+                  </a:schemeClr>
+                </a:solidFill>
+                <a:latin typeface="Comic Sans MS" panose="030F0902030302020204" pitchFamily="66" charset="0"/>
+              </a:rPr>
+              <a:t>21-08-2025</a:t>
+            </a:r>
+          </a:p>
+        </p:txBody>
+      </p:sp>
+      <p:sp>
+        <p:nvSpPr>
+          <p:cNvPr id="77" name="Oval 76">
+            <a:extLst>
+              <a:ext uri="{FF2B5EF4-FFF2-40B4-BE49-F238E27FC236}">
+                <a16:creationId xmlns:a16="http://schemas.microsoft.com/office/drawing/2014/main" id="{CF928CFE-EEE8-E34A-A6C4-A71C79CDDD7C}"/>
+              </a:ext>
+            </a:extLst>
+          </p:cNvPr>
+          <p:cNvSpPr/>
+          <p:nvPr/>
+        </p:nvSpPr>
+        <p:spPr>
+          <a:xfrm>
+            <a:off x="2347102" y="4198979"/>
+            <a:ext cx="127000" cy="127000"/>
+          </a:xfrm>
+          <a:prstGeom prst="ellipse">
+            <a:avLst/>
+          </a:prstGeom>
+          <a:solidFill>
+            <a:srgbClr val="FF8C00"/>
+          </a:solidFill>
+          <a:ln>
+            <a:solidFill>
+              <a:srgbClr val="FF8C00"/>
+            </a:solidFill>
+          </a:ln>
+        </p:spPr>
+        <p:style>
+          <a:lnRef idx="1">
+            <a:schemeClr val="accent1"/>
+          </a:lnRef>
+          <a:fillRef idx="3">
+            <a:schemeClr val="accent1"/>
+          </a:fillRef>
+          <a:effectRef idx="2">
+            <a:schemeClr val="accent1"/>
+          </a:effectRef>
+          <a:fontRef idx="minor">
+            <a:schemeClr val="lt1"/>
+          </a:fontRef>
+        </p:style>
+        <p:txBody>
+          <a:bodyPr rtlCol="0" anchor="ctr"/>
+          <a:lstStyle/>
+          <a:p>
+            <a:pPr algn="ctr"/>
+            <a:endParaRPr>
+              <a:latin typeface="Comic Sans MS" panose="030F0902030302020204" pitchFamily="66" charset="0"/>
+            </a:endParaRPr>
+          </a:p>
+        </p:txBody>
+      </p:sp>
+      <p:cxnSp>
+        <p:nvCxnSpPr>
+          <p:cNvPr id="82" name="Straight Arrow Connector 81">
+            <a:extLst>
+              <a:ext uri="{FF2B5EF4-FFF2-40B4-BE49-F238E27FC236}">
+                <a16:creationId xmlns:a16="http://schemas.microsoft.com/office/drawing/2014/main" id="{B6F9D3BD-D09C-6140-A21C-CFBE59EE5370}"/>
+              </a:ext>
+            </a:extLst>
+          </p:cNvPr>
+          <p:cNvCxnSpPr>
+            <a:endCxn id="77" idx="7"/>
+          </p:cNvCxnSpPr>
+          <p:nvPr/>
+        </p:nvCxnSpPr>
+        <p:spPr>
+          <a:xfrm flipH="1">
+            <a:off x="2455503" y="3058686"/>
+            <a:ext cx="27146" cy="1158892"/>
+          </a:xfrm>
+          <a:prstGeom prst="straightConnector1">
+            <a:avLst/>
+          </a:prstGeom>
+          <a:ln>
+            <a:headEnd type="triangle"/>
+            <a:tailEnd type="triangle"/>
+          </a:ln>
+        </p:spPr>
+        <p:style>
+          <a:lnRef idx="2">
+            <a:schemeClr val="accent1"/>
+          </a:lnRef>
+          <a:fillRef idx="0">
+            <a:schemeClr val="accent1"/>
+          </a:fillRef>
+          <a:effectRef idx="1">
+            <a:schemeClr val="accent1"/>
+          </a:effectRef>
+          <a:fontRef idx="minor">
+            <a:schemeClr val="tx1"/>
+          </a:fontRef>
+        </p:style>
+      </p:cxnSp>
+    </p:spTree>
+    <p:extLst>
+      <p:ext uri="{BB962C8B-B14F-4D97-AF65-F5344CB8AC3E}">
+        <p14:creationId xmlns:p14="http://schemas.microsoft.com/office/powerpoint/2010/main" val="4168491107"/>
+      </p:ext>
+    </p:extLst>
   </p:cSld>
   <p:clrMapOvr>
     <a:masterClrMapping/>

</xml_diff>

<commit_message>
feat: avance en tarea-202508230740
</commit_message>
<xml_diff>
--- a/documentacion/2025-DJANGO-5-BY-EXAMPLE_gitflow_2025.pptx
+++ b/documentacion/2025-DJANGO-5-BY-EXAMPLE_gitflow_2025.pptx
@@ -7724,6 +7724,699 @@
           <a:xfrm flipH="1">
             <a:off x="2455503" y="3058686"/>
             <a:ext cx="27146" cy="1158892"/>
+          </a:xfrm>
+          <a:prstGeom prst="straightConnector1">
+            <a:avLst/>
+          </a:prstGeom>
+          <a:ln>
+            <a:headEnd type="triangle"/>
+            <a:tailEnd type="triangle"/>
+          </a:ln>
+        </p:spPr>
+        <p:style>
+          <a:lnRef idx="2">
+            <a:schemeClr val="accent1"/>
+          </a:lnRef>
+          <a:fillRef idx="0">
+            <a:schemeClr val="accent1"/>
+          </a:fillRef>
+          <a:effectRef idx="1">
+            <a:schemeClr val="accent1"/>
+          </a:effectRef>
+          <a:fontRef idx="minor">
+            <a:schemeClr val="tx1"/>
+          </a:fontRef>
+        </p:style>
+      </p:cxnSp>
+      <p:sp>
+        <p:nvSpPr>
+          <p:cNvPr id="47" name="TextBox 46">
+            <a:extLst>
+              <a:ext uri="{FF2B5EF4-FFF2-40B4-BE49-F238E27FC236}">
+                <a16:creationId xmlns:a16="http://schemas.microsoft.com/office/drawing/2014/main" id="{AB1F7126-BA5A-D947-AAEA-6FB2DEAF1B31}"/>
+              </a:ext>
+            </a:extLst>
+          </p:cNvPr>
+          <p:cNvSpPr txBox="1"/>
+          <p:nvPr/>
+        </p:nvSpPr>
+        <p:spPr>
+          <a:xfrm>
+            <a:off x="3700929" y="2025444"/>
+            <a:ext cx="1237839" cy="338554"/>
+          </a:xfrm>
+          <a:prstGeom prst="rect">
+            <a:avLst/>
+          </a:prstGeom>
+          <a:noFill/>
+          <a:ln>
+            <a:solidFill>
+              <a:schemeClr val="tx2"/>
+            </a:solidFill>
+          </a:ln>
+        </p:spPr>
+        <p:txBody>
+          <a:bodyPr wrap="none">
+            <a:spAutoFit/>
+          </a:bodyPr>
+          <a:lstStyle/>
+          <a:p>
+            <a:r>
+              <a:rPr lang="en-US" sz="800" dirty="0">
+                <a:solidFill>
+                  <a:schemeClr val="tx2">
+                    <a:lumMod val="60000"/>
+                    <a:lumOff val="40000"/>
+                  </a:schemeClr>
+                </a:solidFill>
+                <a:latin typeface="Comic Sans MS" panose="030F0902030302020204" pitchFamily="66" charset="0"/>
+              </a:rPr>
+              <a:t>tarea-202508230740</a:t>
+            </a:r>
+          </a:p>
+          <a:p>
+            <a:r>
+              <a:rPr lang="en-US" sz="800" dirty="0">
+                <a:solidFill>
+                  <a:schemeClr val="tx2">
+                    <a:lumMod val="60000"/>
+                    <a:lumOff val="40000"/>
+                  </a:schemeClr>
+                </a:solidFill>
+                <a:latin typeface="Comic Sans MS" panose="030F0902030302020204" pitchFamily="66" charset="0"/>
+              </a:rPr>
+              <a:t>23-08-2025</a:t>
+            </a:r>
+            <a:endParaRPr sz="800" dirty="0">
+              <a:solidFill>
+                <a:schemeClr val="tx2">
+                  <a:lumMod val="60000"/>
+                  <a:lumOff val="40000"/>
+                </a:schemeClr>
+              </a:solidFill>
+              <a:latin typeface="Comic Sans MS" panose="030F0902030302020204" pitchFamily="66" charset="0"/>
+            </a:endParaRPr>
+          </a:p>
+        </p:txBody>
+      </p:sp>
+      <p:cxnSp>
+        <p:nvCxnSpPr>
+          <p:cNvPr id="48" name="Connector 54">
+            <a:extLst>
+              <a:ext uri="{FF2B5EF4-FFF2-40B4-BE49-F238E27FC236}">
+                <a16:creationId xmlns:a16="http://schemas.microsoft.com/office/drawing/2014/main" id="{9525CF31-DF0C-874A-97FF-8CECFB6C93AC}"/>
+              </a:ext>
+            </a:extLst>
+          </p:cNvPr>
+          <p:cNvCxnSpPr>
+            <a:cxnSpLocks/>
+            <a:stCxn id="63" idx="0"/>
+            <a:endCxn id="47" idx="2"/>
+          </p:cNvCxnSpPr>
+          <p:nvPr/>
+        </p:nvCxnSpPr>
+        <p:spPr>
+          <a:xfrm rot="16200000" flipV="1">
+            <a:off x="4181079" y="2502769"/>
+            <a:ext cx="486931" cy="209390"/>
+          </a:xfrm>
+          <a:prstGeom prst="bentConnector3">
+            <a:avLst/>
+          </a:prstGeom>
+          <a:ln w="19050">
+            <a:solidFill>
+              <a:srgbClr val="808080"/>
+            </a:solidFill>
+            <a:prstDash val="dash"/>
+          </a:ln>
+        </p:spPr>
+        <p:style>
+          <a:lnRef idx="2">
+            <a:schemeClr val="accent1"/>
+          </a:lnRef>
+          <a:fillRef idx="0">
+            <a:schemeClr val="accent1"/>
+          </a:fillRef>
+          <a:effectRef idx="1">
+            <a:schemeClr val="accent1"/>
+          </a:effectRef>
+          <a:fontRef idx="minor">
+            <a:schemeClr val="tx1"/>
+          </a:fontRef>
+        </p:style>
+      </p:cxnSp>
+      <p:sp>
+        <p:nvSpPr>
+          <p:cNvPr id="49" name="Oval 48">
+            <a:extLst>
+              <a:ext uri="{FF2B5EF4-FFF2-40B4-BE49-F238E27FC236}">
+                <a16:creationId xmlns:a16="http://schemas.microsoft.com/office/drawing/2014/main" id="{A3348CDC-DC35-B844-87A4-83060AC2F4ED}"/>
+              </a:ext>
+            </a:extLst>
+          </p:cNvPr>
+          <p:cNvSpPr/>
+          <p:nvPr/>
+        </p:nvSpPr>
+        <p:spPr>
+          <a:xfrm>
+            <a:off x="4039466" y="1579706"/>
+            <a:ext cx="127000" cy="127000"/>
+          </a:xfrm>
+          <a:prstGeom prst="ellipse">
+            <a:avLst/>
+          </a:prstGeom>
+          <a:solidFill>
+            <a:srgbClr val="1E90FF"/>
+          </a:solidFill>
+          <a:ln>
+            <a:solidFill>
+              <a:srgbClr val="1E90FF"/>
+            </a:solidFill>
+          </a:ln>
+        </p:spPr>
+        <p:style>
+          <a:lnRef idx="1">
+            <a:schemeClr val="accent1"/>
+          </a:lnRef>
+          <a:fillRef idx="3">
+            <a:schemeClr val="accent1"/>
+          </a:fillRef>
+          <a:effectRef idx="2">
+            <a:schemeClr val="accent1"/>
+          </a:effectRef>
+          <a:fontRef idx="minor">
+            <a:schemeClr val="lt1"/>
+          </a:fontRef>
+        </p:style>
+        <p:txBody>
+          <a:bodyPr rtlCol="0" anchor="ctr"/>
+          <a:lstStyle/>
+          <a:p>
+            <a:pPr algn="ctr"/>
+            <a:endParaRPr>
+              <a:latin typeface="Comic Sans MS" panose="030F0902030302020204" pitchFamily="66" charset="0"/>
+            </a:endParaRPr>
+          </a:p>
+        </p:txBody>
+      </p:sp>
+      <p:cxnSp>
+        <p:nvCxnSpPr>
+          <p:cNvPr id="51" name="Straight Arrow Connector 50">
+            <a:extLst>
+              <a:ext uri="{FF2B5EF4-FFF2-40B4-BE49-F238E27FC236}">
+                <a16:creationId xmlns:a16="http://schemas.microsoft.com/office/drawing/2014/main" id="{7BEC8FCA-65E4-6048-A05F-6C594D07A10C}"/>
+              </a:ext>
+            </a:extLst>
+          </p:cNvPr>
+          <p:cNvCxnSpPr>
+            <a:cxnSpLocks/>
+            <a:stCxn id="49" idx="5"/>
+            <a:endCxn id="47" idx="0"/>
+          </p:cNvCxnSpPr>
+          <p:nvPr/>
+        </p:nvCxnSpPr>
+        <p:spPr>
+          <a:xfrm>
+            <a:off x="4147867" y="1688107"/>
+            <a:ext cx="171982" cy="337337"/>
+          </a:xfrm>
+          <a:prstGeom prst="straightConnector1">
+            <a:avLst/>
+          </a:prstGeom>
+          <a:ln>
+            <a:tailEnd type="triangle"/>
+          </a:ln>
+        </p:spPr>
+        <p:style>
+          <a:lnRef idx="2">
+            <a:schemeClr val="accent1"/>
+          </a:lnRef>
+          <a:fillRef idx="0">
+            <a:schemeClr val="accent1"/>
+          </a:fillRef>
+          <a:effectRef idx="1">
+            <a:schemeClr val="accent1"/>
+          </a:effectRef>
+          <a:fontRef idx="minor">
+            <a:schemeClr val="tx1"/>
+          </a:fontRef>
+        </p:style>
+      </p:cxnSp>
+      <p:sp>
+        <p:nvSpPr>
+          <p:cNvPr id="55" name="TextBox 54">
+            <a:extLst>
+              <a:ext uri="{FF2B5EF4-FFF2-40B4-BE49-F238E27FC236}">
+                <a16:creationId xmlns:a16="http://schemas.microsoft.com/office/drawing/2014/main" id="{E0283526-B3A5-CE40-A828-1ABA9AF6B4F8}"/>
+              </a:ext>
+            </a:extLst>
+          </p:cNvPr>
+          <p:cNvSpPr txBox="1"/>
+          <p:nvPr/>
+        </p:nvSpPr>
+        <p:spPr>
+          <a:xfrm>
+            <a:off x="4119955" y="4031824"/>
+            <a:ext cx="771365" cy="215444"/>
+          </a:xfrm>
+          <a:prstGeom prst="rect">
+            <a:avLst/>
+          </a:prstGeom>
+          <a:noFill/>
+        </p:spPr>
+        <p:txBody>
+          <a:bodyPr wrap="none" rtlCol="0">
+            <a:spAutoFit/>
+          </a:bodyPr>
+          <a:lstStyle/>
+          <a:p>
+            <a:r>
+              <a:rPr lang="en-US" sz="800" dirty="0">
+                <a:solidFill>
+                  <a:schemeClr val="accent6"/>
+                </a:solidFill>
+                <a:latin typeface="Comic Sans MS" panose="030F0902030302020204" pitchFamily="66" charset="0"/>
+              </a:rPr>
+              <a:t>23-08-2025</a:t>
+            </a:r>
+          </a:p>
+        </p:txBody>
+      </p:sp>
+      <p:sp>
+        <p:nvSpPr>
+          <p:cNvPr id="56" name="Oval 55">
+            <a:extLst>
+              <a:ext uri="{FF2B5EF4-FFF2-40B4-BE49-F238E27FC236}">
+                <a16:creationId xmlns:a16="http://schemas.microsoft.com/office/drawing/2014/main" id="{200801B1-B7D7-6C42-88E9-133D7ADC57B7}"/>
+              </a:ext>
+            </a:extLst>
+          </p:cNvPr>
+          <p:cNvSpPr/>
+          <p:nvPr/>
+        </p:nvSpPr>
+        <p:spPr>
+          <a:xfrm>
+            <a:off x="4537700" y="1062048"/>
+            <a:ext cx="251999" cy="251999"/>
+          </a:xfrm>
+          <a:prstGeom prst="ellipse">
+            <a:avLst/>
+          </a:prstGeom>
+          <a:solidFill>
+            <a:srgbClr val="1E90FF"/>
+          </a:solidFill>
+          <a:ln>
+            <a:solidFill>
+              <a:srgbClr val="1E90FF"/>
+            </a:solidFill>
+          </a:ln>
+        </p:spPr>
+        <p:style>
+          <a:lnRef idx="1">
+            <a:schemeClr val="accent1"/>
+          </a:lnRef>
+          <a:fillRef idx="3">
+            <a:schemeClr val="accent1"/>
+          </a:fillRef>
+          <a:effectRef idx="2">
+            <a:schemeClr val="accent1"/>
+          </a:effectRef>
+          <a:fontRef idx="minor">
+            <a:schemeClr val="lt1"/>
+          </a:fontRef>
+        </p:style>
+        <p:txBody>
+          <a:bodyPr rtlCol="0" anchor="ctr"/>
+          <a:lstStyle/>
+          <a:p>
+            <a:pPr algn="ctr"/>
+            <a:r>
+              <a:rPr lang="es-ES" sz="1400" dirty="0">
+                <a:latin typeface="Comic Sans MS" panose="030F0902030302020204" pitchFamily="66" charset="0"/>
+              </a:rPr>
+              <a:t>C</a:t>
+            </a:r>
+            <a:endParaRPr sz="1400" dirty="0">
+              <a:latin typeface="Comic Sans MS" panose="030F0902030302020204" pitchFamily="66" charset="0"/>
+            </a:endParaRPr>
+          </a:p>
+        </p:txBody>
+      </p:sp>
+      <p:sp>
+        <p:nvSpPr>
+          <p:cNvPr id="60" name="Oval 59">
+            <a:extLst>
+              <a:ext uri="{FF2B5EF4-FFF2-40B4-BE49-F238E27FC236}">
+                <a16:creationId xmlns:a16="http://schemas.microsoft.com/office/drawing/2014/main" id="{2D711259-8125-C443-98E7-7AB4C7FA15D1}"/>
+              </a:ext>
+            </a:extLst>
+          </p:cNvPr>
+          <p:cNvSpPr/>
+          <p:nvPr/>
+        </p:nvSpPr>
+        <p:spPr>
+          <a:xfrm>
+            <a:off x="4554227" y="1345058"/>
+            <a:ext cx="251999" cy="251999"/>
+          </a:xfrm>
+          <a:prstGeom prst="ellipse">
+            <a:avLst/>
+          </a:prstGeom>
+          <a:solidFill>
+            <a:srgbClr val="1E90FF"/>
+          </a:solidFill>
+          <a:ln>
+            <a:solidFill>
+              <a:srgbClr val="1E90FF"/>
+            </a:solidFill>
+          </a:ln>
+        </p:spPr>
+        <p:style>
+          <a:lnRef idx="1">
+            <a:schemeClr val="accent1"/>
+          </a:lnRef>
+          <a:fillRef idx="3">
+            <a:schemeClr val="accent1"/>
+          </a:fillRef>
+          <a:effectRef idx="2">
+            <a:schemeClr val="accent1"/>
+          </a:effectRef>
+          <a:fontRef idx="minor">
+            <a:schemeClr val="lt1"/>
+          </a:fontRef>
+        </p:style>
+        <p:txBody>
+          <a:bodyPr rtlCol="0" anchor="ctr"/>
+          <a:lstStyle/>
+          <a:p>
+            <a:pPr algn="ctr"/>
+            <a:r>
+              <a:rPr lang="es-ES" sz="1400" dirty="0">
+                <a:latin typeface="Comic Sans MS" panose="030F0902030302020204" pitchFamily="66" charset="0"/>
+              </a:rPr>
+              <a:t>P</a:t>
+            </a:r>
+            <a:endParaRPr sz="1400" dirty="0">
+              <a:latin typeface="Comic Sans MS" panose="030F0902030302020204" pitchFamily="66" charset="0"/>
+            </a:endParaRPr>
+          </a:p>
+        </p:txBody>
+      </p:sp>
+      <p:cxnSp>
+        <p:nvCxnSpPr>
+          <p:cNvPr id="61" name="Straight Connector 60">
+            <a:extLst>
+              <a:ext uri="{FF2B5EF4-FFF2-40B4-BE49-F238E27FC236}">
+                <a16:creationId xmlns:a16="http://schemas.microsoft.com/office/drawing/2014/main" id="{5C98D47A-2DB5-B64E-975F-A8AA7181AB8E}"/>
+              </a:ext>
+            </a:extLst>
+          </p:cNvPr>
+          <p:cNvCxnSpPr>
+            <a:cxnSpLocks/>
+            <a:stCxn id="56" idx="2"/>
+            <a:endCxn id="49" idx="0"/>
+          </p:cNvCxnSpPr>
+          <p:nvPr/>
+        </p:nvCxnSpPr>
+        <p:spPr>
+          <a:xfrm flipH="1">
+            <a:off x="4102966" y="1188048"/>
+            <a:ext cx="434734" cy="391658"/>
+          </a:xfrm>
+          <a:prstGeom prst="line">
+            <a:avLst/>
+          </a:prstGeom>
+        </p:spPr>
+        <p:style>
+          <a:lnRef idx="2">
+            <a:schemeClr val="accent1"/>
+          </a:lnRef>
+          <a:fillRef idx="0">
+            <a:schemeClr val="accent1"/>
+          </a:fillRef>
+          <a:effectRef idx="1">
+            <a:schemeClr val="accent1"/>
+          </a:effectRef>
+          <a:fontRef idx="minor">
+            <a:schemeClr val="tx1"/>
+          </a:fontRef>
+        </p:style>
+      </p:cxnSp>
+      <p:cxnSp>
+        <p:nvCxnSpPr>
+          <p:cNvPr id="62" name="Straight Connector 61">
+            <a:extLst>
+              <a:ext uri="{FF2B5EF4-FFF2-40B4-BE49-F238E27FC236}">
+                <a16:creationId xmlns:a16="http://schemas.microsoft.com/office/drawing/2014/main" id="{6ECD2BF3-022E-774D-9DAD-48EF59B6E591}"/>
+              </a:ext>
+            </a:extLst>
+          </p:cNvPr>
+          <p:cNvCxnSpPr>
+            <a:cxnSpLocks/>
+            <a:stCxn id="60" idx="4"/>
+            <a:endCxn id="49" idx="6"/>
+          </p:cNvCxnSpPr>
+          <p:nvPr/>
+        </p:nvCxnSpPr>
+        <p:spPr>
+          <a:xfrm flipH="1">
+            <a:off x="4166466" y="1597057"/>
+            <a:ext cx="513761" cy="46149"/>
+          </a:xfrm>
+          <a:prstGeom prst="line">
+            <a:avLst/>
+          </a:prstGeom>
+        </p:spPr>
+        <p:style>
+          <a:lnRef idx="2">
+            <a:schemeClr val="accent1"/>
+          </a:lnRef>
+          <a:fillRef idx="0">
+            <a:schemeClr val="accent1"/>
+          </a:fillRef>
+          <a:effectRef idx="1">
+            <a:schemeClr val="accent1"/>
+          </a:effectRef>
+          <a:fontRef idx="minor">
+            <a:schemeClr val="tx1"/>
+          </a:fontRef>
+        </p:style>
+      </p:cxnSp>
+      <p:sp>
+        <p:nvSpPr>
+          <p:cNvPr id="63" name="TextBox 62">
+            <a:extLst>
+              <a:ext uri="{FF2B5EF4-FFF2-40B4-BE49-F238E27FC236}">
+                <a16:creationId xmlns:a16="http://schemas.microsoft.com/office/drawing/2014/main" id="{4DAD53CE-08B9-8447-906C-14A6E5F3EBCA}"/>
+              </a:ext>
+            </a:extLst>
+          </p:cNvPr>
+          <p:cNvSpPr txBox="1"/>
+          <p:nvPr/>
+        </p:nvSpPr>
+        <p:spPr>
+          <a:xfrm>
+            <a:off x="3607352" y="2850929"/>
+            <a:ext cx="1843774" cy="230832"/>
+          </a:xfrm>
+          <a:prstGeom prst="rect">
+            <a:avLst/>
+          </a:prstGeom>
+          <a:noFill/>
+        </p:spPr>
+        <p:txBody>
+          <a:bodyPr wrap="none">
+            <a:spAutoFit/>
+          </a:bodyPr>
+          <a:lstStyle/>
+          <a:p>
+            <a:r>
+              <a:rPr lang="es-ES" sz="900" dirty="0" err="1">
+                <a:solidFill>
+                  <a:srgbClr val="505050"/>
+                </a:solidFill>
+                <a:latin typeface="Comic Sans MS" panose="030F0902030302020204" pitchFamily="66" charset="0"/>
+              </a:rPr>
+              <a:t>feature</a:t>
+            </a:r>
+            <a:r>
+              <a:rPr lang="es-ES" sz="900" dirty="0">
+                <a:solidFill>
+                  <a:srgbClr val="505050"/>
+                </a:solidFill>
+                <a:latin typeface="Comic Sans MS" panose="030F0902030302020204" pitchFamily="66" charset="0"/>
+              </a:rPr>
+              <a:t>/tarea-202508230740</a:t>
+            </a:r>
+            <a:endParaRPr sz="900" dirty="0">
+              <a:solidFill>
+                <a:srgbClr val="505050"/>
+              </a:solidFill>
+              <a:latin typeface="Comic Sans MS" panose="030F0902030302020204" pitchFamily="66" charset="0"/>
+            </a:endParaRPr>
+          </a:p>
+        </p:txBody>
+      </p:sp>
+      <p:sp>
+        <p:nvSpPr>
+          <p:cNvPr id="64" name="TextBox 63">
+            <a:extLst>
+              <a:ext uri="{FF2B5EF4-FFF2-40B4-BE49-F238E27FC236}">
+                <a16:creationId xmlns:a16="http://schemas.microsoft.com/office/drawing/2014/main" id="{2AE8C76B-151B-BC4F-9E08-963238E8761E}"/>
+              </a:ext>
+            </a:extLst>
+          </p:cNvPr>
+          <p:cNvSpPr txBox="1"/>
+          <p:nvPr/>
+        </p:nvSpPr>
+        <p:spPr>
+          <a:xfrm>
+            <a:off x="4774766" y="1082096"/>
+            <a:ext cx="771365" cy="215444"/>
+          </a:xfrm>
+          <a:prstGeom prst="rect">
+            <a:avLst/>
+          </a:prstGeom>
+          <a:noFill/>
+        </p:spPr>
+        <p:txBody>
+          <a:bodyPr wrap="none" rtlCol="0">
+            <a:spAutoFit/>
+          </a:bodyPr>
+          <a:lstStyle/>
+          <a:p>
+            <a:r>
+              <a:rPr lang="en-US" sz="800" dirty="0">
+                <a:solidFill>
+                  <a:schemeClr val="tx2">
+                    <a:lumMod val="60000"/>
+                    <a:lumOff val="40000"/>
+                  </a:schemeClr>
+                </a:solidFill>
+                <a:latin typeface="Comic Sans MS" panose="030F0902030302020204" pitchFamily="66" charset="0"/>
+              </a:rPr>
+              <a:t>23-08-2025</a:t>
+            </a:r>
+          </a:p>
+        </p:txBody>
+      </p:sp>
+      <p:sp>
+        <p:nvSpPr>
+          <p:cNvPr id="73" name="TextBox 72">
+            <a:extLst>
+              <a:ext uri="{FF2B5EF4-FFF2-40B4-BE49-F238E27FC236}">
+                <a16:creationId xmlns:a16="http://schemas.microsoft.com/office/drawing/2014/main" id="{4A99CB60-D2E5-9646-8352-0941A07D78A7}"/>
+              </a:ext>
+            </a:extLst>
+          </p:cNvPr>
+          <p:cNvSpPr txBox="1"/>
+          <p:nvPr/>
+        </p:nvSpPr>
+        <p:spPr>
+          <a:xfrm>
+            <a:off x="4841480" y="1400990"/>
+            <a:ext cx="771365" cy="215444"/>
+          </a:xfrm>
+          <a:prstGeom prst="rect">
+            <a:avLst/>
+          </a:prstGeom>
+          <a:noFill/>
+        </p:spPr>
+        <p:txBody>
+          <a:bodyPr wrap="none" rtlCol="0">
+            <a:spAutoFit/>
+          </a:bodyPr>
+          <a:lstStyle/>
+          <a:p>
+            <a:r>
+              <a:rPr lang="en-US" sz="800" dirty="0">
+                <a:solidFill>
+                  <a:schemeClr val="tx2">
+                    <a:lumMod val="60000"/>
+                    <a:lumOff val="40000"/>
+                  </a:schemeClr>
+                </a:solidFill>
+                <a:latin typeface="Comic Sans MS" panose="030F0902030302020204" pitchFamily="66" charset="0"/>
+              </a:rPr>
+              <a:t>23-08-2025</a:t>
+            </a:r>
+          </a:p>
+        </p:txBody>
+      </p:sp>
+      <p:sp>
+        <p:nvSpPr>
+          <p:cNvPr id="74" name="Oval 73">
+            <a:extLst>
+              <a:ext uri="{FF2B5EF4-FFF2-40B4-BE49-F238E27FC236}">
+                <a16:creationId xmlns:a16="http://schemas.microsoft.com/office/drawing/2014/main" id="{FD1ADED8-53A4-A84F-A240-846B6874DB8A}"/>
+              </a:ext>
+            </a:extLst>
+          </p:cNvPr>
+          <p:cNvSpPr/>
+          <p:nvPr/>
+        </p:nvSpPr>
+        <p:spPr>
+          <a:xfrm>
+            <a:off x="4001215" y="4205472"/>
+            <a:ext cx="127000" cy="127000"/>
+          </a:xfrm>
+          <a:prstGeom prst="ellipse">
+            <a:avLst/>
+          </a:prstGeom>
+          <a:solidFill>
+            <a:srgbClr val="FF8C00"/>
+          </a:solidFill>
+          <a:ln>
+            <a:solidFill>
+              <a:srgbClr val="FF8C00"/>
+            </a:solidFill>
+          </a:ln>
+        </p:spPr>
+        <p:style>
+          <a:lnRef idx="1">
+            <a:schemeClr val="accent1"/>
+          </a:lnRef>
+          <a:fillRef idx="3">
+            <a:schemeClr val="accent1"/>
+          </a:fillRef>
+          <a:effectRef idx="2">
+            <a:schemeClr val="accent1"/>
+          </a:effectRef>
+          <a:fontRef idx="minor">
+            <a:schemeClr val="lt1"/>
+          </a:fontRef>
+        </p:style>
+        <p:txBody>
+          <a:bodyPr rtlCol="0" anchor="ctr"/>
+          <a:lstStyle/>
+          <a:p>
+            <a:pPr algn="ctr"/>
+            <a:endParaRPr>
+              <a:latin typeface="Comic Sans MS" panose="030F0902030302020204" pitchFamily="66" charset="0"/>
+            </a:endParaRPr>
+          </a:p>
+        </p:txBody>
+      </p:sp>
+      <p:cxnSp>
+        <p:nvCxnSpPr>
+          <p:cNvPr id="78" name="Straight Arrow Connector 77">
+            <a:extLst>
+              <a:ext uri="{FF2B5EF4-FFF2-40B4-BE49-F238E27FC236}">
+                <a16:creationId xmlns:a16="http://schemas.microsoft.com/office/drawing/2014/main" id="{0CAA0028-B0BF-C34B-9DC3-1259714EC81D}"/>
+              </a:ext>
+            </a:extLst>
+          </p:cNvPr>
+          <p:cNvCxnSpPr>
+            <a:cxnSpLocks/>
+            <a:stCxn id="63" idx="2"/>
+            <a:endCxn id="74" idx="7"/>
+          </p:cNvCxnSpPr>
+          <p:nvPr/>
+        </p:nvCxnSpPr>
+        <p:spPr>
+          <a:xfrm flipH="1">
+            <a:off x="4109616" y="3081761"/>
+            <a:ext cx="419623" cy="1142310"/>
           </a:xfrm>
           <a:prstGeom prst="straightConnector1">
             <a:avLst/>

</xml_diff>